<commit_message>
fix(step-5): label the recall-gap sign convention, add the after-gap interval, align figure DPI
</commit_message>
<xml_diff>
--- a/presentations/technical.pptx
+++ b/presentations/technical.pptx
@@ -7118,7 +7118,7 @@
                 </a:solidFill>
                 <a:latin typeface="Calibri"/>
               </a:rPr>
-              <a:t> at a cutoff chosen against staffing, on enrollment-time data only. The shipped system adds the exponentiated-gradient fairness fix, recall 0.718, gender gap down from 0.177 to 0.009.</a:t>
+              <a:t> at a cutoff chosen against staffing, on enrollment-time data only. The shipped system adds the exponentiated-gradient fairness fix, recall 0.718, gender gap from a real 0.177 to 0.009, which spans zero.</a:t>
             </a:r>
           </a:p>
           <a:p>
@@ -7193,7 +7193,7 @@
                 </a:solidFill>
                 <a:latin typeface="Calibri"/>
               </a:rPr>
-              <a:t>The fair model decides who is on the list</a:t>
+              <a:t>The fair model picks the list</a:t>
             </a:r>
             <a:r>
               <a:rPr sz="1200" b="0">
@@ -7202,7 +7202,7 @@
                 </a:solidFill>
                 <a:latin typeface="Calibri"/>
               </a:rPr>
-              <a:t>, the base model orders it, and the fair set of 410 fits the 450 the team can staff.</a:t>
+              <a:t>, the base model orders it, and the fair set of 410 fits capacity.</a:t>
             </a:r>
           </a:p>
         </p:txBody>

</xml_diff>

<commit_message>
feat(step-9): add a GenAI explanation layer with a guardrail verifier
Turn SHAP values into a tutor's note via Gemini, race a naive prompt against a guarded one, and verify the guardrail mechanically (naive 0/5, guarded 5/5). Runs keyless for a grader off a committed response cache. Adds a report section, a technical-deck bonus slide, and README notes.
</commit_message>
<xml_diff>
--- a/presentations/technical.pptx
+++ b/presentations/technical.pptx
@@ -17,6 +17,7 @@
     <p:sldId id="265" r:id="rId16"/>
     <p:sldId id="266" r:id="rId17"/>
     <p:sldId id="267" r:id="rId18"/>
+    <p:sldId id="268" r:id="rId19"/>
   </p:sldIdLst>
   <p:sldSz cx="12191695" cy="6858000" type="screen4x3"/>
   <p:notesSz cx="6858000" cy="9144000"/>
@@ -7530,6 +7531,529 @@
                 <a:latin typeface="Calibri"/>
               </a:rPr>
               <a:t>A dropout model is not a scoreboard. It is a decision about which students get help. The right way to use this one is as a ranked prompt for a support team, checked by a person.</a:t>
+            </a:r>
+          </a:p>
+        </p:txBody>
+      </p:sp>
+    </p:spTree>
+  </p:cSld>
+  <p:clrMapOvr>
+    <a:masterClrMapping/>
+  </p:clrMapOvr>
+</p:sld>
+</file>
+
+<file path=ppt/slides/slide13.xml><?xml version="1.0" encoding="utf-8"?>
+<p:sld xmlns:a="http://schemas.openxmlformats.org/drawingml/2006/main" xmlns:p="http://schemas.openxmlformats.org/presentationml/2006/main" xmlns:r="http://schemas.openxmlformats.org/officeDocument/2006/relationships">
+  <p:cSld>
+    <p:spTree>
+      <p:nvGrpSpPr>
+        <p:cNvPr id="1" name=""/>
+        <p:cNvGrpSpPr/>
+        <p:nvPr/>
+      </p:nvGrpSpPr>
+      <p:grpSpPr/>
+      <p:sp>
+        <p:nvSpPr>
+          <p:cNvPr id="2" name="TextBox 1"/>
+          <p:cNvSpPr txBox="1"/>
+          <p:nvPr/>
+        </p:nvSpPr>
+        <p:spPr>
+          <a:xfrm>
+            <a:off x="566928" y="457200"/>
+            <a:ext cx="11057839" cy="548640"/>
+          </a:xfrm>
+          <a:prstGeom prst="rect">
+            <a:avLst/>
+          </a:prstGeom>
+          <a:noFill/>
+        </p:spPr>
+        <p:txBody>
+          <a:bodyPr wrap="square" lIns="0" rIns="0" tIns="0" bIns="0">
+            <a:spAutoFit/>
+          </a:bodyPr>
+          <a:lstStyle/>
+          <a:p>
+            <a:pPr algn="l">
+              <a:spcAft>
+                <a:spcPts val="600"/>
+              </a:spcAft>
+            </a:pPr>
+            <a:r>
+              <a:rPr sz="2900" b="1">
+                <a:solidFill>
+                  <a:srgbClr val="1A1A1A"/>
+                </a:solidFill>
+                <a:latin typeface="Cambria"/>
+              </a:rPr>
+              <a:t>Bonus. A language model, kept behind a verifier</a:t>
+            </a:r>
+          </a:p>
+        </p:txBody>
+      </p:sp>
+      <p:sp>
+        <p:nvSpPr>
+          <p:cNvPr id="3" name="TextBox 2"/>
+          <p:cNvSpPr txBox="1"/>
+          <p:nvPr/>
+        </p:nvSpPr>
+        <p:spPr>
+          <a:xfrm>
+            <a:off x="566928" y="1033271"/>
+            <a:ext cx="11057839" cy="274320"/>
+          </a:xfrm>
+          <a:prstGeom prst="rect">
+            <a:avLst/>
+          </a:prstGeom>
+          <a:noFill/>
+        </p:spPr>
+        <p:txBody>
+          <a:bodyPr wrap="square" lIns="0" rIns="0" tIns="0" bIns="0">
+            <a:spAutoFit/>
+          </a:bodyPr>
+          <a:lstStyle/>
+          <a:p>
+            <a:pPr algn="l">
+              <a:spcAft>
+                <a:spcPts val="600"/>
+              </a:spcAft>
+            </a:pPr>
+            <a:r>
+              <a:rPr sz="1200" b="0">
+                <a:solidFill>
+                  <a:srgbClr val="595959"/>
+                </a:solidFill>
+                <a:latin typeface="Calibri"/>
+              </a:rPr>
+              <a:t>SHAP values a tutor cannot read, turned into a note a tutor can act on. Step 9, optional.</a:t>
+            </a:r>
+          </a:p>
+        </p:txBody>
+      </p:sp>
+      <p:sp>
+        <p:nvSpPr>
+          <p:cNvPr id="4" name="TextBox 3"/>
+          <p:cNvSpPr txBox="1"/>
+          <p:nvPr/>
+        </p:nvSpPr>
+        <p:spPr>
+          <a:xfrm>
+            <a:off x="566928" y="1600200"/>
+            <a:ext cx="6126480" cy="4389120"/>
+          </a:xfrm>
+          <a:prstGeom prst="rect">
+            <a:avLst/>
+          </a:prstGeom>
+          <a:noFill/>
+        </p:spPr>
+        <p:txBody>
+          <a:bodyPr wrap="square" lIns="0" rIns="0" tIns="0" bIns="0">
+            <a:spAutoFit/>
+          </a:bodyPr>
+          <a:lstStyle/>
+          <a:p>
+            <a:pPr algn="l">
+              <a:lnSpc>
+                <a:spcPct val="125000"/>
+              </a:lnSpc>
+              <a:spcAft>
+                <a:spcPts val="900"/>
+              </a:spcAft>
+            </a:pPr>
+            <a:r>
+              <a:rPr sz="1300" b="0">
+                <a:solidFill>
+                  <a:srgbClr val="595959"/>
+                </a:solidFill>
+                <a:latin typeface="Calibri"/>
+              </a:rPr>
+              <a:t>SHAP says </a:t>
+            </a:r>
+            <a:r>
+              <a:rPr sz="1300" b="1">
+                <a:solidFill>
+                  <a:srgbClr val="1A1A1A"/>
+                </a:solidFill>
+                <a:latin typeface="Calibri"/>
+              </a:rPr>
+              <a:t>Tuition fees up to date: +0.68</a:t>
+            </a:r>
+            <a:r>
+              <a:rPr sz="1300" b="0">
+                <a:solidFill>
+                  <a:srgbClr val="595959"/>
+                </a:solidFill>
+                <a:latin typeface="Calibri"/>
+              </a:rPr>
+              <a:t>. True, and useless to the tutor who picks up the phone. A language model turns a student's top drivers into two plain sentences, which is the one thing it is genuinely good for here.</a:t>
+            </a:r>
+          </a:p>
+          <a:p>
+            <a:pPr algn="l">
+              <a:lnSpc>
+                <a:spcPct val="125000"/>
+              </a:lnSpc>
+              <a:spcAft>
+                <a:spcPts val="900"/>
+              </a:spcAft>
+            </a:pPr>
+            <a:r>
+              <a:rPr sz="1300" b="1">
+                <a:solidFill>
+                  <a:srgbClr val="1A1A1A"/>
+                </a:solidFill>
+                <a:latin typeface="Calibri"/>
+              </a:rPr>
+              <a:t>Handed the numbers with no rules, it does the forbidden thing</a:t>
+            </a:r>
+            <a:r>
+              <a:rPr sz="1300" b="0">
+                <a:solidFill>
+                  <a:srgbClr val="595959"/>
+                </a:solidFill>
+                <a:latin typeface="Calibri"/>
+              </a:rPr>
+              <a:t>. It prints probabilities and admission scores, reads a mother's occupation as low status, and names the student's gender. So the guarded prompt bans numbers, scoring words, any off-list driver, and gender, though the model leans on it at SHAP 0.301.</a:t>
+            </a:r>
+          </a:p>
+          <a:p>
+            <a:pPr algn="l">
+              <a:lnSpc>
+                <a:spcPct val="125000"/>
+              </a:lnSpc>
+              <a:spcAft>
+                <a:spcPts val="900"/>
+              </a:spcAft>
+            </a:pPr>
+            <a:r>
+              <a:rPr sz="1300" b="1">
+                <a:solidFill>
+                  <a:srgbClr val="1A1A1A"/>
+                </a:solidFill>
+                <a:latin typeface="Calibri"/>
+              </a:rPr>
+              <a:t>Then a cell checks the prompt actually held.</a:t>
+            </a:r>
+            <a:r>
+              <a:rPr sz="1300" b="0">
+                <a:solidFill>
+                  <a:srgbClr val="595959"/>
+                </a:solidFill>
+                <a:latin typeface="Calibri"/>
+              </a:rPr>
+              <a:t> The rules-engine baseline passes by construction. The language model has to be watched.</a:t>
+            </a:r>
+          </a:p>
+        </p:txBody>
+      </p:sp>
+      <p:sp>
+        <p:nvSpPr>
+          <p:cNvPr id="5" name="TextBox 4"/>
+          <p:cNvSpPr txBox="1"/>
+          <p:nvPr/>
+        </p:nvSpPr>
+        <p:spPr>
+          <a:xfrm>
+            <a:off x="6903720" y="1691640"/>
+            <a:ext cx="2377440" cy="603504"/>
+          </a:xfrm>
+          <a:prstGeom prst="rect">
+            <a:avLst/>
+          </a:prstGeom>
+          <a:noFill/>
+        </p:spPr>
+        <p:txBody>
+          <a:bodyPr wrap="square" lIns="0" rIns="0" tIns="0" bIns="0">
+            <a:spAutoFit/>
+          </a:bodyPr>
+          <a:lstStyle/>
+          <a:p>
+            <a:pPr algn="l">
+              <a:spcAft>
+                <a:spcPts val="0"/>
+              </a:spcAft>
+            </a:pPr>
+            <a:r>
+              <a:rPr sz="4400" b="1">
+                <a:solidFill>
+                  <a:srgbClr val="1A1A1A"/>
+                </a:solidFill>
+                <a:latin typeface="Cambria"/>
+              </a:rPr>
+              <a:t>0 / 5</a:t>
+            </a:r>
+          </a:p>
+        </p:txBody>
+      </p:sp>
+      <p:sp>
+        <p:nvSpPr>
+          <p:cNvPr id="6" name="TextBox 5"/>
+          <p:cNvSpPr txBox="1"/>
+          <p:nvPr/>
+        </p:nvSpPr>
+        <p:spPr>
+          <a:xfrm>
+            <a:off x="6903720" y="2261616"/>
+            <a:ext cx="2377440" cy="457200"/>
+          </a:xfrm>
+          <a:prstGeom prst="rect">
+            <a:avLst/>
+          </a:prstGeom>
+          <a:noFill/>
+        </p:spPr>
+        <p:txBody>
+          <a:bodyPr wrap="square" lIns="0" rIns="0" tIns="0" bIns="0">
+            <a:spAutoFit/>
+          </a:bodyPr>
+          <a:lstStyle/>
+          <a:p>
+            <a:pPr algn="l">
+              <a:lnSpc>
+                <a:spcPct val="115000"/>
+              </a:lnSpc>
+              <a:spcAft>
+                <a:spcPts val="600"/>
+              </a:spcAft>
+            </a:pPr>
+            <a:r>
+              <a:rPr sz="1100" b="0">
+                <a:solidFill>
+                  <a:srgbClr val="767676"/>
+                </a:solidFill>
+                <a:latin typeface="Calibri"/>
+              </a:rPr>
+              <a:t>naive prompt safe to read</a:t>
+            </a:r>
+          </a:p>
+        </p:txBody>
+      </p:sp>
+      <p:sp>
+        <p:nvSpPr>
+          <p:cNvPr id="7" name="TextBox 6"/>
+          <p:cNvSpPr txBox="1"/>
+          <p:nvPr/>
+        </p:nvSpPr>
+        <p:spPr>
+          <a:xfrm>
+            <a:off x="9418320" y="1691640"/>
+            <a:ext cx="2377440" cy="603504"/>
+          </a:xfrm>
+          <a:prstGeom prst="rect">
+            <a:avLst/>
+          </a:prstGeom>
+          <a:noFill/>
+        </p:spPr>
+        <p:txBody>
+          <a:bodyPr wrap="square" lIns="0" rIns="0" tIns="0" bIns="0">
+            <a:spAutoFit/>
+          </a:bodyPr>
+          <a:lstStyle/>
+          <a:p>
+            <a:pPr algn="l">
+              <a:spcAft>
+                <a:spcPts val="0"/>
+              </a:spcAft>
+            </a:pPr>
+            <a:r>
+              <a:rPr sz="4400" b="1">
+                <a:solidFill>
+                  <a:srgbClr val="F6861F"/>
+                </a:solidFill>
+                <a:latin typeface="Cambria"/>
+              </a:rPr>
+              <a:t>5 / 5</a:t>
+            </a:r>
+          </a:p>
+        </p:txBody>
+      </p:sp>
+      <p:sp>
+        <p:nvSpPr>
+          <p:cNvPr id="8" name="TextBox 7"/>
+          <p:cNvSpPr txBox="1"/>
+          <p:nvPr/>
+        </p:nvSpPr>
+        <p:spPr>
+          <a:xfrm>
+            <a:off x="9418320" y="2261616"/>
+            <a:ext cx="2377440" cy="457200"/>
+          </a:xfrm>
+          <a:prstGeom prst="rect">
+            <a:avLst/>
+          </a:prstGeom>
+          <a:noFill/>
+        </p:spPr>
+        <p:txBody>
+          <a:bodyPr wrap="square" lIns="0" rIns="0" tIns="0" bIns="0">
+            <a:spAutoFit/>
+          </a:bodyPr>
+          <a:lstStyle/>
+          <a:p>
+            <a:pPr algn="l">
+              <a:lnSpc>
+                <a:spcPct val="115000"/>
+              </a:lnSpc>
+              <a:spcAft>
+                <a:spcPts val="600"/>
+              </a:spcAft>
+            </a:pPr>
+            <a:r>
+              <a:rPr sz="1100" b="0">
+                <a:solidFill>
+                  <a:srgbClr val="767676"/>
+                </a:solidFill>
+                <a:latin typeface="Calibri"/>
+              </a:rPr>
+              <a:t>guarded prompt safe to read</a:t>
+            </a:r>
+          </a:p>
+        </p:txBody>
+      </p:sp>
+      <p:sp>
+        <p:nvSpPr>
+          <p:cNvPr id="9" name="TextBox 8"/>
+          <p:cNvSpPr txBox="1"/>
+          <p:nvPr/>
+        </p:nvSpPr>
+        <p:spPr>
+          <a:xfrm>
+            <a:off x="6903720" y="3383280"/>
+            <a:ext cx="4800600" cy="2468880"/>
+          </a:xfrm>
+          <a:prstGeom prst="rect">
+            <a:avLst/>
+          </a:prstGeom>
+          <a:noFill/>
+        </p:spPr>
+        <p:txBody>
+          <a:bodyPr wrap="square" lIns="0" rIns="0" tIns="0" bIns="0">
+            <a:spAutoFit/>
+          </a:bodyPr>
+          <a:lstStyle/>
+          <a:p>
+            <a:pPr algn="l">
+              <a:lnSpc>
+                <a:spcPct val="122000"/>
+              </a:lnSpc>
+              <a:spcAft>
+                <a:spcPts val="900"/>
+              </a:spcAft>
+            </a:pPr>
+            <a:r>
+              <a:rPr sz="1200" b="1">
+                <a:solidFill>
+                  <a:srgbClr val="1A1A1A"/>
+                </a:solidFill>
+                <a:latin typeface="Calibri"/>
+              </a:rPr>
+              <a:t>naive  </a:t>
+            </a:r>
+            <a:r>
+              <a:rPr sz="1200" b="0">
+                <a:solidFill>
+                  <a:srgbClr val="595959"/>
+                </a:solidFill>
+                <a:latin typeface="Calibri"/>
+              </a:rPr>
+              <a:t>prints a probability and a rank, and names the student as male. Digits, scoring words, gender.</a:t>
+            </a:r>
+          </a:p>
+          <a:p>
+            <a:pPr algn="l">
+              <a:lnSpc>
+                <a:spcPct val="122000"/>
+              </a:lnSpc>
+              <a:spcAft>
+                <a:spcPts val="900"/>
+              </a:spcAft>
+            </a:pPr>
+            <a:r>
+              <a:rPr sz="1200" b="1">
+                <a:solidFill>
+                  <a:srgbClr val="F6861F"/>
+                </a:solidFill>
+                <a:latin typeface="Calibri"/>
+              </a:rPr>
+              <a:t>guarded  </a:t>
+            </a:r>
+            <a:r>
+              <a:rPr sz="1200" b="0">
+                <a:solidFill>
+                  <a:srgbClr val="595959"/>
+                </a:solidFill>
+                <a:latin typeface="Calibri"/>
+              </a:rPr>
+              <a:t>behind on tuition fees, may need support navigating their course. Plain, and clean.</a:t>
+            </a:r>
+          </a:p>
+          <a:p>
+            <a:pPr algn="l">
+              <a:lnSpc>
+                <a:spcPct val="122000"/>
+              </a:lnSpc>
+              <a:spcAft>
+                <a:spcPts val="900"/>
+              </a:spcAft>
+            </a:pPr>
+            <a:r>
+              <a:rPr sz="1200" b="1">
+                <a:solidFill>
+                  <a:srgbClr val="1A1A1A"/>
+                </a:solidFill>
+                <a:latin typeface="Calibri"/>
+              </a:rPr>
+              <a:t>What it bought</a:t>
+            </a:r>
+            <a:r>
+              <a:rPr sz="1200" b="0">
+                <a:solidFill>
+                  <a:srgbClr val="595959"/>
+                </a:solidFill>
+                <a:latin typeface="Calibri"/>
+              </a:rPr>
+              <a:t>: fluency, and words for the course code and a parent's occupation the table refuses to touch, and one note that over-reached. The verifier is necessary, not sufficient.</a:t>
+            </a:r>
+          </a:p>
+        </p:txBody>
+      </p:sp>
+      <p:sp>
+        <p:nvSpPr>
+          <p:cNvPr id="10" name="TextBox 9"/>
+          <p:cNvSpPr txBox="1"/>
+          <p:nvPr/>
+        </p:nvSpPr>
+        <p:spPr>
+          <a:xfrm>
+            <a:off x="566928" y="6236208"/>
+            <a:ext cx="11057839" cy="411480"/>
+          </a:xfrm>
+          <a:prstGeom prst="rect">
+            <a:avLst/>
+          </a:prstGeom>
+          <a:noFill/>
+        </p:spPr>
+        <p:txBody>
+          <a:bodyPr wrap="square" lIns="0" rIns="0" tIns="0" bIns="0">
+            <a:spAutoFit/>
+          </a:bodyPr>
+          <a:lstStyle/>
+          <a:p>
+            <a:pPr algn="l">
+              <a:lnSpc>
+                <a:spcPct val="115000"/>
+              </a:lnSpc>
+              <a:spcAft>
+                <a:spcPts val="600"/>
+              </a:spcAft>
+            </a:pPr>
+            <a:r>
+              <a:rPr sz="1300" b="1">
+                <a:solidFill>
+                  <a:srgbClr val="1A1A1A"/>
+                </a:solidFill>
+                <a:latin typeface="Calibri"/>
+              </a:rPr>
+              <a:t>A prompt is a request. The verifier is the control. The whole notebook runs for a grader with no key, off a committed cache of every prompt and every response.</a:t>
             </a:r>
           </a:p>
         </p:txBody>

</xml_diff>

<commit_message>
feat(step-9): move the GenAI bonus into its own deck
Revert the technical deck to 12 slides so both graded decks stay within the 8-12 the rubric asks for, and add a separate 4-slide GenAI bonus deck. Rebuild the submission bundle to carry it, with a one-page cover in the report's plain 12pt house style.
</commit_message>
<xml_diff>
--- a/presentations/technical.pptx
+++ b/presentations/technical.pptx
@@ -17,7 +17,6 @@
     <p:sldId id="265" r:id="rId16"/>
     <p:sldId id="266" r:id="rId17"/>
     <p:sldId id="267" r:id="rId18"/>
-    <p:sldId id="268" r:id="rId19"/>
   </p:sldIdLst>
   <p:sldSz cx="12191695" cy="6858000" type="screen4x3"/>
   <p:notesSz cx="6858000" cy="9144000"/>
@@ -7531,529 +7530,6 @@
                 <a:latin typeface="Calibri"/>
               </a:rPr>
               <a:t>A dropout model is not a scoreboard. It is a decision about which students get help. The right way to use this one is as a ranked prompt for a support team, checked by a person.</a:t>
-            </a:r>
-          </a:p>
-        </p:txBody>
-      </p:sp>
-    </p:spTree>
-  </p:cSld>
-  <p:clrMapOvr>
-    <a:masterClrMapping/>
-  </p:clrMapOvr>
-</p:sld>
-</file>
-
-<file path=ppt/slides/slide13.xml><?xml version="1.0" encoding="utf-8"?>
-<p:sld xmlns:a="http://schemas.openxmlformats.org/drawingml/2006/main" xmlns:p="http://schemas.openxmlformats.org/presentationml/2006/main" xmlns:r="http://schemas.openxmlformats.org/officeDocument/2006/relationships">
-  <p:cSld>
-    <p:spTree>
-      <p:nvGrpSpPr>
-        <p:cNvPr id="1" name=""/>
-        <p:cNvGrpSpPr/>
-        <p:nvPr/>
-      </p:nvGrpSpPr>
-      <p:grpSpPr/>
-      <p:sp>
-        <p:nvSpPr>
-          <p:cNvPr id="2" name="TextBox 1"/>
-          <p:cNvSpPr txBox="1"/>
-          <p:nvPr/>
-        </p:nvSpPr>
-        <p:spPr>
-          <a:xfrm>
-            <a:off x="566928" y="457200"/>
-            <a:ext cx="11057839" cy="548640"/>
-          </a:xfrm>
-          <a:prstGeom prst="rect">
-            <a:avLst/>
-          </a:prstGeom>
-          <a:noFill/>
-        </p:spPr>
-        <p:txBody>
-          <a:bodyPr wrap="square" lIns="0" rIns="0" tIns="0" bIns="0">
-            <a:spAutoFit/>
-          </a:bodyPr>
-          <a:lstStyle/>
-          <a:p>
-            <a:pPr algn="l">
-              <a:spcAft>
-                <a:spcPts val="600"/>
-              </a:spcAft>
-            </a:pPr>
-            <a:r>
-              <a:rPr sz="2900" b="1">
-                <a:solidFill>
-                  <a:srgbClr val="1A1A1A"/>
-                </a:solidFill>
-                <a:latin typeface="Cambria"/>
-              </a:rPr>
-              <a:t>Bonus. A language model, kept behind a verifier</a:t>
-            </a:r>
-          </a:p>
-        </p:txBody>
-      </p:sp>
-      <p:sp>
-        <p:nvSpPr>
-          <p:cNvPr id="3" name="TextBox 2"/>
-          <p:cNvSpPr txBox="1"/>
-          <p:nvPr/>
-        </p:nvSpPr>
-        <p:spPr>
-          <a:xfrm>
-            <a:off x="566928" y="1033271"/>
-            <a:ext cx="11057839" cy="274320"/>
-          </a:xfrm>
-          <a:prstGeom prst="rect">
-            <a:avLst/>
-          </a:prstGeom>
-          <a:noFill/>
-        </p:spPr>
-        <p:txBody>
-          <a:bodyPr wrap="square" lIns="0" rIns="0" tIns="0" bIns="0">
-            <a:spAutoFit/>
-          </a:bodyPr>
-          <a:lstStyle/>
-          <a:p>
-            <a:pPr algn="l">
-              <a:spcAft>
-                <a:spcPts val="600"/>
-              </a:spcAft>
-            </a:pPr>
-            <a:r>
-              <a:rPr sz="1200" b="0">
-                <a:solidFill>
-                  <a:srgbClr val="595959"/>
-                </a:solidFill>
-                <a:latin typeface="Calibri"/>
-              </a:rPr>
-              <a:t>SHAP values a tutor cannot read, turned into a note a tutor can act on. Step 9, optional.</a:t>
-            </a:r>
-          </a:p>
-        </p:txBody>
-      </p:sp>
-      <p:sp>
-        <p:nvSpPr>
-          <p:cNvPr id="4" name="TextBox 3"/>
-          <p:cNvSpPr txBox="1"/>
-          <p:nvPr/>
-        </p:nvSpPr>
-        <p:spPr>
-          <a:xfrm>
-            <a:off x="566928" y="1600200"/>
-            <a:ext cx="6126480" cy="4389120"/>
-          </a:xfrm>
-          <a:prstGeom prst="rect">
-            <a:avLst/>
-          </a:prstGeom>
-          <a:noFill/>
-        </p:spPr>
-        <p:txBody>
-          <a:bodyPr wrap="square" lIns="0" rIns="0" tIns="0" bIns="0">
-            <a:spAutoFit/>
-          </a:bodyPr>
-          <a:lstStyle/>
-          <a:p>
-            <a:pPr algn="l">
-              <a:lnSpc>
-                <a:spcPct val="125000"/>
-              </a:lnSpc>
-              <a:spcAft>
-                <a:spcPts val="900"/>
-              </a:spcAft>
-            </a:pPr>
-            <a:r>
-              <a:rPr sz="1300" b="0">
-                <a:solidFill>
-                  <a:srgbClr val="595959"/>
-                </a:solidFill>
-                <a:latin typeface="Calibri"/>
-              </a:rPr>
-              <a:t>SHAP says </a:t>
-            </a:r>
-            <a:r>
-              <a:rPr sz="1300" b="1">
-                <a:solidFill>
-                  <a:srgbClr val="1A1A1A"/>
-                </a:solidFill>
-                <a:latin typeface="Calibri"/>
-              </a:rPr>
-              <a:t>Tuition fees up to date: +0.68</a:t>
-            </a:r>
-            <a:r>
-              <a:rPr sz="1300" b="0">
-                <a:solidFill>
-                  <a:srgbClr val="595959"/>
-                </a:solidFill>
-                <a:latin typeface="Calibri"/>
-              </a:rPr>
-              <a:t>. True, and useless to the tutor who picks up the phone. A language model turns a student's top drivers into two plain sentences, which is the one thing it is genuinely good for here.</a:t>
-            </a:r>
-          </a:p>
-          <a:p>
-            <a:pPr algn="l">
-              <a:lnSpc>
-                <a:spcPct val="125000"/>
-              </a:lnSpc>
-              <a:spcAft>
-                <a:spcPts val="900"/>
-              </a:spcAft>
-            </a:pPr>
-            <a:r>
-              <a:rPr sz="1300" b="1">
-                <a:solidFill>
-                  <a:srgbClr val="1A1A1A"/>
-                </a:solidFill>
-                <a:latin typeface="Calibri"/>
-              </a:rPr>
-              <a:t>Handed the numbers with no rules, it does the forbidden thing</a:t>
-            </a:r>
-            <a:r>
-              <a:rPr sz="1300" b="0">
-                <a:solidFill>
-                  <a:srgbClr val="595959"/>
-                </a:solidFill>
-                <a:latin typeface="Calibri"/>
-              </a:rPr>
-              <a:t>. It prints probabilities and admission scores, reads a mother's occupation as low status, and names the student's gender. So the guarded prompt bans numbers, scoring words, any off-list driver, and gender, though the model leans on it at SHAP 0.301.</a:t>
-            </a:r>
-          </a:p>
-          <a:p>
-            <a:pPr algn="l">
-              <a:lnSpc>
-                <a:spcPct val="125000"/>
-              </a:lnSpc>
-              <a:spcAft>
-                <a:spcPts val="900"/>
-              </a:spcAft>
-            </a:pPr>
-            <a:r>
-              <a:rPr sz="1300" b="1">
-                <a:solidFill>
-                  <a:srgbClr val="1A1A1A"/>
-                </a:solidFill>
-                <a:latin typeface="Calibri"/>
-              </a:rPr>
-              <a:t>Then a cell checks the prompt actually held.</a:t>
-            </a:r>
-            <a:r>
-              <a:rPr sz="1300" b="0">
-                <a:solidFill>
-                  <a:srgbClr val="595959"/>
-                </a:solidFill>
-                <a:latin typeface="Calibri"/>
-              </a:rPr>
-              <a:t> The rules-engine baseline passes by construction. The language model has to be watched.</a:t>
-            </a:r>
-          </a:p>
-        </p:txBody>
-      </p:sp>
-      <p:sp>
-        <p:nvSpPr>
-          <p:cNvPr id="5" name="TextBox 4"/>
-          <p:cNvSpPr txBox="1"/>
-          <p:nvPr/>
-        </p:nvSpPr>
-        <p:spPr>
-          <a:xfrm>
-            <a:off x="6903720" y="1691640"/>
-            <a:ext cx="2377440" cy="603504"/>
-          </a:xfrm>
-          <a:prstGeom prst="rect">
-            <a:avLst/>
-          </a:prstGeom>
-          <a:noFill/>
-        </p:spPr>
-        <p:txBody>
-          <a:bodyPr wrap="square" lIns="0" rIns="0" tIns="0" bIns="0">
-            <a:spAutoFit/>
-          </a:bodyPr>
-          <a:lstStyle/>
-          <a:p>
-            <a:pPr algn="l">
-              <a:spcAft>
-                <a:spcPts val="0"/>
-              </a:spcAft>
-            </a:pPr>
-            <a:r>
-              <a:rPr sz="4400" b="1">
-                <a:solidFill>
-                  <a:srgbClr val="1A1A1A"/>
-                </a:solidFill>
-                <a:latin typeface="Cambria"/>
-              </a:rPr>
-              <a:t>0 / 5</a:t>
-            </a:r>
-          </a:p>
-        </p:txBody>
-      </p:sp>
-      <p:sp>
-        <p:nvSpPr>
-          <p:cNvPr id="6" name="TextBox 5"/>
-          <p:cNvSpPr txBox="1"/>
-          <p:nvPr/>
-        </p:nvSpPr>
-        <p:spPr>
-          <a:xfrm>
-            <a:off x="6903720" y="2261616"/>
-            <a:ext cx="2377440" cy="457200"/>
-          </a:xfrm>
-          <a:prstGeom prst="rect">
-            <a:avLst/>
-          </a:prstGeom>
-          <a:noFill/>
-        </p:spPr>
-        <p:txBody>
-          <a:bodyPr wrap="square" lIns="0" rIns="0" tIns="0" bIns="0">
-            <a:spAutoFit/>
-          </a:bodyPr>
-          <a:lstStyle/>
-          <a:p>
-            <a:pPr algn="l">
-              <a:lnSpc>
-                <a:spcPct val="115000"/>
-              </a:lnSpc>
-              <a:spcAft>
-                <a:spcPts val="600"/>
-              </a:spcAft>
-            </a:pPr>
-            <a:r>
-              <a:rPr sz="1100" b="0">
-                <a:solidFill>
-                  <a:srgbClr val="767676"/>
-                </a:solidFill>
-                <a:latin typeface="Calibri"/>
-              </a:rPr>
-              <a:t>naive prompt safe to read</a:t>
-            </a:r>
-          </a:p>
-        </p:txBody>
-      </p:sp>
-      <p:sp>
-        <p:nvSpPr>
-          <p:cNvPr id="7" name="TextBox 6"/>
-          <p:cNvSpPr txBox="1"/>
-          <p:nvPr/>
-        </p:nvSpPr>
-        <p:spPr>
-          <a:xfrm>
-            <a:off x="9418320" y="1691640"/>
-            <a:ext cx="2377440" cy="603504"/>
-          </a:xfrm>
-          <a:prstGeom prst="rect">
-            <a:avLst/>
-          </a:prstGeom>
-          <a:noFill/>
-        </p:spPr>
-        <p:txBody>
-          <a:bodyPr wrap="square" lIns="0" rIns="0" tIns="0" bIns="0">
-            <a:spAutoFit/>
-          </a:bodyPr>
-          <a:lstStyle/>
-          <a:p>
-            <a:pPr algn="l">
-              <a:spcAft>
-                <a:spcPts val="0"/>
-              </a:spcAft>
-            </a:pPr>
-            <a:r>
-              <a:rPr sz="4400" b="1">
-                <a:solidFill>
-                  <a:srgbClr val="F6861F"/>
-                </a:solidFill>
-                <a:latin typeface="Cambria"/>
-              </a:rPr>
-              <a:t>5 / 5</a:t>
-            </a:r>
-          </a:p>
-        </p:txBody>
-      </p:sp>
-      <p:sp>
-        <p:nvSpPr>
-          <p:cNvPr id="8" name="TextBox 7"/>
-          <p:cNvSpPr txBox="1"/>
-          <p:nvPr/>
-        </p:nvSpPr>
-        <p:spPr>
-          <a:xfrm>
-            <a:off x="9418320" y="2261616"/>
-            <a:ext cx="2377440" cy="457200"/>
-          </a:xfrm>
-          <a:prstGeom prst="rect">
-            <a:avLst/>
-          </a:prstGeom>
-          <a:noFill/>
-        </p:spPr>
-        <p:txBody>
-          <a:bodyPr wrap="square" lIns="0" rIns="0" tIns="0" bIns="0">
-            <a:spAutoFit/>
-          </a:bodyPr>
-          <a:lstStyle/>
-          <a:p>
-            <a:pPr algn="l">
-              <a:lnSpc>
-                <a:spcPct val="115000"/>
-              </a:lnSpc>
-              <a:spcAft>
-                <a:spcPts val="600"/>
-              </a:spcAft>
-            </a:pPr>
-            <a:r>
-              <a:rPr sz="1100" b="0">
-                <a:solidFill>
-                  <a:srgbClr val="767676"/>
-                </a:solidFill>
-                <a:latin typeface="Calibri"/>
-              </a:rPr>
-              <a:t>guarded prompt safe to read</a:t>
-            </a:r>
-          </a:p>
-        </p:txBody>
-      </p:sp>
-      <p:sp>
-        <p:nvSpPr>
-          <p:cNvPr id="9" name="TextBox 8"/>
-          <p:cNvSpPr txBox="1"/>
-          <p:nvPr/>
-        </p:nvSpPr>
-        <p:spPr>
-          <a:xfrm>
-            <a:off x="6903720" y="3383280"/>
-            <a:ext cx="4800600" cy="2468880"/>
-          </a:xfrm>
-          <a:prstGeom prst="rect">
-            <a:avLst/>
-          </a:prstGeom>
-          <a:noFill/>
-        </p:spPr>
-        <p:txBody>
-          <a:bodyPr wrap="square" lIns="0" rIns="0" tIns="0" bIns="0">
-            <a:spAutoFit/>
-          </a:bodyPr>
-          <a:lstStyle/>
-          <a:p>
-            <a:pPr algn="l">
-              <a:lnSpc>
-                <a:spcPct val="122000"/>
-              </a:lnSpc>
-              <a:spcAft>
-                <a:spcPts val="900"/>
-              </a:spcAft>
-            </a:pPr>
-            <a:r>
-              <a:rPr sz="1200" b="1">
-                <a:solidFill>
-                  <a:srgbClr val="1A1A1A"/>
-                </a:solidFill>
-                <a:latin typeface="Calibri"/>
-              </a:rPr>
-              <a:t>naive  </a:t>
-            </a:r>
-            <a:r>
-              <a:rPr sz="1200" b="0">
-                <a:solidFill>
-                  <a:srgbClr val="595959"/>
-                </a:solidFill>
-                <a:latin typeface="Calibri"/>
-              </a:rPr>
-              <a:t>prints a probability and a rank, and names the student as male. Digits, scoring words, gender.</a:t>
-            </a:r>
-          </a:p>
-          <a:p>
-            <a:pPr algn="l">
-              <a:lnSpc>
-                <a:spcPct val="122000"/>
-              </a:lnSpc>
-              <a:spcAft>
-                <a:spcPts val="900"/>
-              </a:spcAft>
-            </a:pPr>
-            <a:r>
-              <a:rPr sz="1200" b="1">
-                <a:solidFill>
-                  <a:srgbClr val="F6861F"/>
-                </a:solidFill>
-                <a:latin typeface="Calibri"/>
-              </a:rPr>
-              <a:t>guarded  </a:t>
-            </a:r>
-            <a:r>
-              <a:rPr sz="1200" b="0">
-                <a:solidFill>
-                  <a:srgbClr val="595959"/>
-                </a:solidFill>
-                <a:latin typeface="Calibri"/>
-              </a:rPr>
-              <a:t>behind on tuition fees, may need support navigating their course. Plain, and clean.</a:t>
-            </a:r>
-          </a:p>
-          <a:p>
-            <a:pPr algn="l">
-              <a:lnSpc>
-                <a:spcPct val="122000"/>
-              </a:lnSpc>
-              <a:spcAft>
-                <a:spcPts val="900"/>
-              </a:spcAft>
-            </a:pPr>
-            <a:r>
-              <a:rPr sz="1200" b="1">
-                <a:solidFill>
-                  <a:srgbClr val="1A1A1A"/>
-                </a:solidFill>
-                <a:latin typeface="Calibri"/>
-              </a:rPr>
-              <a:t>What it bought</a:t>
-            </a:r>
-            <a:r>
-              <a:rPr sz="1200" b="0">
-                <a:solidFill>
-                  <a:srgbClr val="595959"/>
-                </a:solidFill>
-                <a:latin typeface="Calibri"/>
-              </a:rPr>
-              <a:t>: fluency, and words for the course code and a parent's occupation the table refuses to touch, and one note that over-reached. The verifier is necessary, not sufficient.</a:t>
-            </a:r>
-          </a:p>
-        </p:txBody>
-      </p:sp>
-      <p:sp>
-        <p:nvSpPr>
-          <p:cNvPr id="10" name="TextBox 9"/>
-          <p:cNvSpPr txBox="1"/>
-          <p:nvPr/>
-        </p:nvSpPr>
-        <p:spPr>
-          <a:xfrm>
-            <a:off x="566928" y="6236208"/>
-            <a:ext cx="11057839" cy="411480"/>
-          </a:xfrm>
-          <a:prstGeom prst="rect">
-            <a:avLst/>
-          </a:prstGeom>
-          <a:noFill/>
-        </p:spPr>
-        <p:txBody>
-          <a:bodyPr wrap="square" lIns="0" rIns="0" tIns="0" bIns="0">
-            <a:spAutoFit/>
-          </a:bodyPr>
-          <a:lstStyle/>
-          <a:p>
-            <a:pPr algn="l">
-              <a:lnSpc>
-                <a:spcPct val="115000"/>
-              </a:lnSpc>
-              <a:spcAft>
-                <a:spcPts val="600"/>
-              </a:spcAft>
-            </a:pPr>
-            <a:r>
-              <a:rPr sz="1300" b="1">
-                <a:solidFill>
-                  <a:srgbClr val="1A1A1A"/>
-                </a:solidFill>
-                <a:latin typeface="Calibri"/>
-              </a:rPr>
-              <a:t>A prompt is a request. The verifier is the control. The whole notebook runs for a grader with no key, off a committed cache of every prompt and every response.</a:t>
             </a:r>
           </a:p>
         </p:txBody>

</xml_diff>